<commit_message>
Deck v5: add go-to-market engine to shipped list; portable builder + regenerated PDF/PPTX
Co-authored-by: museibrahim1 <museibrahim1@users.noreply.github.com>
</commit_message>
<xml_diff>
--- a/marketing/pitch-deck-v5/PalmCare_Deck_v5.pptx
+++ b/marketing/pitch-deck-v5/PalmCare_Deck_v5.pptx
@@ -2116,7 +2116,7 @@
       </p:grpSpPr>
       <p:pic>
         <p:nvPicPr>
-          <p:cNvPr id="2" name="Image 0" descr="/Users/musaibrahim/Desktop/AI Voice Contracter/marketing/pitch-deck-v5/out/s01-title.png">    </p:cNvPr>
+          <p:cNvPr id="2" name="Image 0" descr="/workspace/marketing/pitch-deck-v5/out/s01-title.png">    </p:cNvPr>
           <p:cNvPicPr>
             <a:picLocks noChangeAspect="1"/>
           </p:cNvPicPr>
@@ -2165,7 +2165,7 @@
       </p:grpSpPr>
       <p:pic>
         <p:nvPicPr>
-          <p:cNvPr id="2" name="Image 0" descr="/Users/musaibrahim/Desktop/AI Voice Contracter/marketing/pitch-deck-v5/out/s10-whynow.png">    </p:cNvPr>
+          <p:cNvPr id="2" name="Image 0" descr="/workspace/marketing/pitch-deck-v5/out/s10-whynow.png">    </p:cNvPr>
           <p:cNvPicPr>
             <a:picLocks noChangeAspect="1"/>
           </p:cNvPicPr>
@@ -2214,7 +2214,7 @@
       </p:grpSpPr>
       <p:pic>
         <p:nvPicPr>
-          <p:cNvPr id="2" name="Image 0" descr="/Users/musaibrahim/Desktop/AI Voice Contracter/marketing/pitch-deck-v5/out/s11-financials.png">    </p:cNvPr>
+          <p:cNvPr id="2" name="Image 0" descr="/workspace/marketing/pitch-deck-v5/out/s11-financials.png">    </p:cNvPr>
           <p:cNvPicPr>
             <a:picLocks noChangeAspect="1"/>
           </p:cNvPicPr>
@@ -2263,7 +2263,7 @@
       </p:grpSpPr>
       <p:pic>
         <p:nvPicPr>
-          <p:cNvPr id="2" name="Image 0" descr="/Users/musaibrahim/Desktop/AI Voice Contracter/marketing/pitch-deck-v5/out/s12-roadmap.png">    </p:cNvPr>
+          <p:cNvPr id="2" name="Image 0" descr="/workspace/marketing/pitch-deck-v5/out/s12-roadmap.png">    </p:cNvPr>
           <p:cNvPicPr>
             <a:picLocks noChangeAspect="1"/>
           </p:cNvPicPr>
@@ -2312,7 +2312,7 @@
       </p:grpSpPr>
       <p:pic>
         <p:nvPicPr>
-          <p:cNvPr id="2" name="Image 0" descr="/Users/musaibrahim/Desktop/AI Voice Contracter/marketing/pitch-deck-v5/out/s13-ask.png">    </p:cNvPr>
+          <p:cNvPr id="2" name="Image 0" descr="/workspace/marketing/pitch-deck-v5/out/s13-ask.png">    </p:cNvPr>
           <p:cNvPicPr>
             <a:picLocks noChangeAspect="1"/>
           </p:cNvPicPr>
@@ -2361,7 +2361,7 @@
       </p:grpSpPr>
       <p:pic>
         <p:nvPicPr>
-          <p:cNvPr id="2" name="Image 0" descr="/Users/musaibrahim/Desktop/AI Voice Contracter/marketing/pitch-deck-v5/out/s14-team.png">    </p:cNvPr>
+          <p:cNvPr id="2" name="Image 0" descr="/workspace/marketing/pitch-deck-v5/out/s14-team.png">    </p:cNvPr>
           <p:cNvPicPr>
             <a:picLocks noChangeAspect="1"/>
           </p:cNvPicPr>
@@ -2410,7 +2410,7 @@
       </p:grpSpPr>
       <p:pic>
         <p:nvPicPr>
-          <p:cNvPr id="2" name="Image 0" descr="/Users/musaibrahim/Desktop/AI Voice Contracter/marketing/pitch-deck-v5/out/s15-close.png">    </p:cNvPr>
+          <p:cNvPr id="2" name="Image 0" descr="/workspace/marketing/pitch-deck-v5/out/s15-close.png">    </p:cNvPr>
           <p:cNvPicPr>
             <a:picLocks noChangeAspect="1"/>
           </p:cNvPicPr>
@@ -2459,7 +2459,7 @@
       </p:grpSpPr>
       <p:pic>
         <p:nvPicPr>
-          <p:cNvPr id="2" name="Image 0" descr="/Users/musaibrahim/Desktop/AI Voice Contracter/marketing/pitch-deck-v5/out/s02-problem.png">    </p:cNvPr>
+          <p:cNvPr id="2" name="Image 0" descr="/workspace/marketing/pitch-deck-v5/out/s02-problem.png">    </p:cNvPr>
           <p:cNvPicPr>
             <a:picLocks noChangeAspect="1"/>
           </p:cNvPicPr>
@@ -2508,7 +2508,7 @@
       </p:grpSpPr>
       <p:pic>
         <p:nvPicPr>
-          <p:cNvPr id="2" name="Image 0" descr="/Users/musaibrahim/Desktop/AI Voice Contracter/marketing/pitch-deck-v5/out/s03-solution.png">    </p:cNvPr>
+          <p:cNvPr id="2" name="Image 0" descr="/workspace/marketing/pitch-deck-v5/out/s03-solution.png">    </p:cNvPr>
           <p:cNvPicPr>
             <a:picLocks noChangeAspect="1"/>
           </p:cNvPicPr>
@@ -2557,7 +2557,7 @@
       </p:grpSpPr>
       <p:pic>
         <p:nvPicPr>
-          <p:cNvPr id="2" name="Image 0" descr="/Users/musaibrahim/Desktop/AI Voice Contracter/marketing/pitch-deck-v5/out/s04-launched.png">    </p:cNvPr>
+          <p:cNvPr id="2" name="Image 0" descr="/workspace/marketing/pitch-deck-v5/out/s04-launched.png">    </p:cNvPr>
           <p:cNvPicPr>
             <a:picLocks noChangeAspect="1"/>
           </p:cNvPicPr>
@@ -2606,7 +2606,7 @@
       </p:grpSpPr>
       <p:pic>
         <p:nvPicPr>
-          <p:cNvPr id="2" name="Image 0" descr="/Users/musaibrahim/Desktop/AI Voice Contracter/marketing/pitch-deck-v5/out/s05-how.png">    </p:cNvPr>
+          <p:cNvPr id="2" name="Image 0" descr="/workspace/marketing/pitch-deck-v5/out/s05-how.png">    </p:cNvPr>
           <p:cNvPicPr>
             <a:picLocks noChangeAspect="1"/>
           </p:cNvPicPr>
@@ -2655,7 +2655,7 @@
       </p:grpSpPr>
       <p:pic>
         <p:nvPicPr>
-          <p:cNvPr id="2" name="Image 0" descr="/Users/musaibrahim/Desktop/AI Voice Contracter/marketing/pitch-deck-v5/out/s06-crm.png">    </p:cNvPr>
+          <p:cNvPr id="2" name="Image 0" descr="/workspace/marketing/pitch-deck-v5/out/s06-crm.png">    </p:cNvPr>
           <p:cNvPicPr>
             <a:picLocks noChangeAspect="1"/>
           </p:cNvPicPr>
@@ -2704,7 +2704,7 @@
       </p:grpSpPr>
       <p:pic>
         <p:nvPicPr>
-          <p:cNvPr id="2" name="Image 0" descr="/Users/musaibrahim/Desktop/AI Voice Contracter/marketing/pitch-deck-v5/out/s07-market.png">    </p:cNvPr>
+          <p:cNvPr id="2" name="Image 0" descr="/workspace/marketing/pitch-deck-v5/out/s07-market.png">    </p:cNvPr>
           <p:cNvPicPr>
             <a:picLocks noChangeAspect="1"/>
           </p:cNvPicPr>
@@ -2753,7 +2753,7 @@
       </p:grpSpPr>
       <p:pic>
         <p:nvPicPr>
-          <p:cNvPr id="2" name="Image 0" descr="/Users/musaibrahim/Desktop/AI Voice Contracter/marketing/pitch-deck-v5/out/s08-competition.png">    </p:cNvPr>
+          <p:cNvPr id="2" name="Image 0" descr="/workspace/marketing/pitch-deck-v5/out/s08-competition.png">    </p:cNvPr>
           <p:cNvPicPr>
             <a:picLocks noChangeAspect="1"/>
           </p:cNvPicPr>
@@ -2802,7 +2802,7 @@
       </p:grpSpPr>
       <p:pic>
         <p:nvPicPr>
-          <p:cNvPr id="2" name="Image 0" descr="/Users/musaibrahim/Desktop/AI Voice Contracter/marketing/pitch-deck-v5/out/s09-model.png">    </p:cNvPr>
+          <p:cNvPr id="2" name="Image 0" descr="/workspace/marketing/pitch-deck-v5/out/s09-model.png">    </p:cNvPr>
           <p:cNvPicPr>
             <a:picLocks noChangeAspect="1"/>
           </p:cNvPicPr>

</xml_diff>